<commit_message>
PPT update: typo and minor
</commit_message>
<xml_diff>
--- a/idr-nlri-error-handling.pptx
+++ b/idr-nlri-error-handling.pptx
@@ -992,7 +992,7 @@
           <a:p>
             <a:fld id="{6B3A3F2F-16EF-5743-9823-704C3351FBC7}" type="datetimeFigureOut">
               <a:rPr lang="en-US" smtClean="0"/>
-              <a:t>10/29/2025</a:t>
+              <a:t>11/2/2025</a:t>
             </a:fld>
             <a:endParaRPr lang="en-US"/>
           </a:p>
@@ -1488,9 +1488,9 @@
           <a:bodyPr/>
           <a:lstStyle/>
           <a:p>
-            <a:fld id="{1942F851-F8A8-476F-9E6F-F7AE7574E7D7}" type="datetimeFigureOut">
+            <a:fld id="{B0C4F60E-1C57-4031-8F6D-404901CFBAE3}" type="datetime1">
               <a:rPr lang="fr-FR" smtClean="0"/>
-              <a:t>29/10/2025</a:t>
+              <a:t>02/11/2025</a:t>
             </a:fld>
             <a:endParaRPr lang="fr-FR"/>
           </a:p>
@@ -1686,9 +1686,9 @@
           <a:bodyPr/>
           <a:lstStyle/>
           <a:p>
-            <a:fld id="{1942F851-F8A8-476F-9E6F-F7AE7574E7D7}" type="datetimeFigureOut">
+            <a:fld id="{7EE48580-C773-42A2-B110-609EB2C948FD}" type="datetime1">
               <a:rPr lang="fr-FR" smtClean="0"/>
-              <a:t>29/10/2025</a:t>
+              <a:t>02/11/2025</a:t>
             </a:fld>
             <a:endParaRPr lang="fr-FR"/>
           </a:p>
@@ -1894,9 +1894,9 @@
           <a:bodyPr/>
           <a:lstStyle/>
           <a:p>
-            <a:fld id="{1942F851-F8A8-476F-9E6F-F7AE7574E7D7}" type="datetimeFigureOut">
+            <a:fld id="{E9CA7948-A502-4F72-868F-2AA3BACCF76F}" type="datetime1">
               <a:rPr lang="fr-FR" smtClean="0"/>
-              <a:t>29/10/2025</a:t>
+              <a:t>02/11/2025</a:t>
             </a:fld>
             <a:endParaRPr lang="fr-FR"/>
           </a:p>
@@ -2092,9 +2092,9 @@
           <a:bodyPr/>
           <a:lstStyle/>
           <a:p>
-            <a:fld id="{1942F851-F8A8-476F-9E6F-F7AE7574E7D7}" type="datetimeFigureOut">
+            <a:fld id="{275C7BC9-8391-4BC6-A916-1681B9412325}" type="datetime1">
               <a:rPr lang="fr-FR" smtClean="0"/>
-              <a:t>29/10/2025</a:t>
+              <a:t>02/11/2025</a:t>
             </a:fld>
             <a:endParaRPr lang="fr-FR"/>
           </a:p>
@@ -2367,9 +2367,9 @@
           <a:bodyPr/>
           <a:lstStyle/>
           <a:p>
-            <a:fld id="{1942F851-F8A8-476F-9E6F-F7AE7574E7D7}" type="datetimeFigureOut">
+            <a:fld id="{DB141985-8FFA-407E-9E6E-659CB5FBD5D9}" type="datetime1">
               <a:rPr lang="fr-FR" smtClean="0"/>
-              <a:t>29/10/2025</a:t>
+              <a:t>02/11/2025</a:t>
             </a:fld>
             <a:endParaRPr lang="fr-FR"/>
           </a:p>
@@ -2632,9 +2632,9 @@
           <a:bodyPr/>
           <a:lstStyle/>
           <a:p>
-            <a:fld id="{1942F851-F8A8-476F-9E6F-F7AE7574E7D7}" type="datetimeFigureOut">
+            <a:fld id="{3DE8EC3E-5E05-4993-998F-072D38715AC3}" type="datetime1">
               <a:rPr lang="fr-FR" smtClean="0"/>
-              <a:t>29/10/2025</a:t>
+              <a:t>02/11/2025</a:t>
             </a:fld>
             <a:endParaRPr lang="fr-FR"/>
           </a:p>
@@ -3044,9 +3044,9 @@
           <a:bodyPr/>
           <a:lstStyle/>
           <a:p>
-            <a:fld id="{1942F851-F8A8-476F-9E6F-F7AE7574E7D7}" type="datetimeFigureOut">
+            <a:fld id="{B7143E07-707B-4355-B212-CBA8B00031C7}" type="datetime1">
               <a:rPr lang="fr-FR" smtClean="0"/>
-              <a:t>29/10/2025</a:t>
+              <a:t>02/11/2025</a:t>
             </a:fld>
             <a:endParaRPr lang="fr-FR"/>
           </a:p>
@@ -3185,9 +3185,9 @@
           <a:bodyPr/>
           <a:lstStyle/>
           <a:p>
-            <a:fld id="{1942F851-F8A8-476F-9E6F-F7AE7574E7D7}" type="datetimeFigureOut">
+            <a:fld id="{A01C05CC-359C-40CB-93F6-460E363EA827}" type="datetime1">
               <a:rPr lang="fr-FR" smtClean="0"/>
-              <a:t>29/10/2025</a:t>
+              <a:t>02/11/2025</a:t>
             </a:fld>
             <a:endParaRPr lang="fr-FR"/>
           </a:p>
@@ -3298,9 +3298,9 @@
           <a:bodyPr/>
           <a:lstStyle/>
           <a:p>
-            <a:fld id="{1942F851-F8A8-476F-9E6F-F7AE7574E7D7}" type="datetimeFigureOut">
+            <a:fld id="{00000FAE-0619-4297-A1CA-0C321C70FADD}" type="datetime1">
               <a:rPr lang="fr-FR" smtClean="0"/>
-              <a:t>29/10/2025</a:t>
+              <a:t>02/11/2025</a:t>
             </a:fld>
             <a:endParaRPr lang="fr-FR"/>
           </a:p>
@@ -3609,9 +3609,9 @@
           <a:bodyPr/>
           <a:lstStyle/>
           <a:p>
-            <a:fld id="{1942F851-F8A8-476F-9E6F-F7AE7574E7D7}" type="datetimeFigureOut">
+            <a:fld id="{BD9C4B96-2F39-47D9-A558-0275DD334FDD}" type="datetime1">
               <a:rPr lang="fr-FR" smtClean="0"/>
-              <a:t>29/10/2025</a:t>
+              <a:t>02/11/2025</a:t>
             </a:fld>
             <a:endParaRPr lang="fr-FR"/>
           </a:p>
@@ -3897,9 +3897,9 @@
           <a:bodyPr/>
           <a:lstStyle/>
           <a:p>
-            <a:fld id="{1942F851-F8A8-476F-9E6F-F7AE7574E7D7}" type="datetimeFigureOut">
+            <a:fld id="{5ED04B57-C5CC-4908-8B2A-32FEFED6A29F}" type="datetime1">
               <a:rPr lang="fr-FR" smtClean="0"/>
-              <a:t>29/10/2025</a:t>
+              <a:t>02/11/2025</a:t>
             </a:fld>
             <a:endParaRPr lang="fr-FR"/>
           </a:p>
@@ -4191,9 +4191,9 @@
             </a:lvl1pPr>
           </a:lstStyle>
           <a:p>
-            <a:fld id="{1942F851-F8A8-476F-9E6F-F7AE7574E7D7}" type="datetimeFigureOut">
+            <a:fld id="{ADB123A2-3948-460E-8A7E-FD62D2B89B8C}" type="datetime1">
               <a:rPr lang="fr-FR" smtClean="0"/>
-              <a:t>29/10/2025</a:t>
+              <a:t>02/11/2025</a:t>
             </a:fld>
             <a:endParaRPr lang="fr-FR"/>
           </a:p>
@@ -4310,6 +4310,7 @@
     <p:sldLayoutId id="2147483658" r:id="rId10"/>
     <p:sldLayoutId id="2147483659" r:id="rId11"/>
   </p:sldLayoutIdLst>
+  <p:hf hdr="0" ftr="0" dt="0"/>
   <p:txStyles>
     <p:titleStyle>
       <a:lvl1pPr algn="l" defTabSz="914400" rtl="0" eaLnBrk="1" latinLnBrk="0" hangingPunct="1">
@@ -4710,6 +4711,35 @@
           </a:p>
         </p:txBody>
       </p:sp>
+      <p:sp>
+        <p:nvSpPr>
+          <p:cNvPr id="4" name="Espace réservé du numéro de diapositive 3">
+            <a:extLst>
+              <a:ext uri="{FF2B5EF4-FFF2-40B4-BE49-F238E27FC236}">
+                <a16:creationId xmlns:a16="http://schemas.microsoft.com/office/drawing/2014/main" id="{9D1F3BD0-D0B2-389C-2B69-D3588B3E4D86}"/>
+              </a:ext>
+            </a:extLst>
+          </p:cNvPr>
+          <p:cNvSpPr>
+            <a:spLocks noGrp="1"/>
+          </p:cNvSpPr>
+          <p:nvPr>
+            <p:ph type="sldNum" sz="quarter" idx="12"/>
+          </p:nvPr>
+        </p:nvSpPr>
+        <p:spPr/>
+        <p:txBody>
+          <a:bodyPr/>
+          <a:lstStyle/>
+          <a:p>
+            <a:fld id="{6EB0AFAF-01AD-403D-8986-94521B07DECF}" type="slidenum">
+              <a:rPr lang="fr-FR" smtClean="0"/>
+              <a:t>1</a:t>
+            </a:fld>
+            <a:endParaRPr lang="fr-FR"/>
+          </a:p>
+        </p:txBody>
+      </p:sp>
     </p:spTree>
     <p:extLst>
       <p:ext uri="{BB962C8B-B14F-4D97-AF65-F5344CB8AC3E}">
@@ -4824,6 +4854,35 @@
           </a:p>
         </p:txBody>
       </p:sp>
+      <p:sp>
+        <p:nvSpPr>
+          <p:cNvPr id="4" name="Espace réservé du numéro de diapositive 3">
+            <a:extLst>
+              <a:ext uri="{FF2B5EF4-FFF2-40B4-BE49-F238E27FC236}">
+                <a16:creationId xmlns:a16="http://schemas.microsoft.com/office/drawing/2014/main" id="{4A9AF404-DF3E-AA86-208A-7E826E2C97B9}"/>
+              </a:ext>
+            </a:extLst>
+          </p:cNvPr>
+          <p:cNvSpPr>
+            <a:spLocks noGrp="1"/>
+          </p:cNvSpPr>
+          <p:nvPr>
+            <p:ph type="sldNum" sz="quarter" idx="12"/>
+          </p:nvPr>
+        </p:nvSpPr>
+        <p:spPr/>
+        <p:txBody>
+          <a:bodyPr/>
+          <a:lstStyle/>
+          <a:p>
+            <a:fld id="{6EB0AFAF-01AD-403D-8986-94521B07DECF}" type="slidenum">
+              <a:rPr lang="fr-FR" smtClean="0"/>
+              <a:t>10</a:t>
+            </a:fld>
+            <a:endParaRPr lang="fr-FR"/>
+          </a:p>
+        </p:txBody>
+      </p:sp>
     </p:spTree>
     <p:extLst>
       <p:ext uri="{BB962C8B-B14F-4D97-AF65-F5344CB8AC3E}">
@@ -4946,6 +5005,35 @@
               <a:t> Parsing all NLRIs is critical to avoid session reset</a:t>
             </a:r>
             <a:endParaRPr lang="en-US" dirty="0"/>
+          </a:p>
+        </p:txBody>
+      </p:sp>
+      <p:sp>
+        <p:nvSpPr>
+          <p:cNvPr id="4" name="Espace réservé du numéro de diapositive 3">
+            <a:extLst>
+              <a:ext uri="{FF2B5EF4-FFF2-40B4-BE49-F238E27FC236}">
+                <a16:creationId xmlns:a16="http://schemas.microsoft.com/office/drawing/2014/main" id="{C7ABC387-04CD-AE8A-88E8-29C0A3616F4F}"/>
+              </a:ext>
+            </a:extLst>
+          </p:cNvPr>
+          <p:cNvSpPr>
+            <a:spLocks noGrp="1"/>
+          </p:cNvSpPr>
+          <p:nvPr>
+            <p:ph type="sldNum" sz="quarter" idx="12"/>
+          </p:nvPr>
+        </p:nvSpPr>
+        <p:spPr/>
+        <p:txBody>
+          <a:bodyPr/>
+          <a:lstStyle/>
+          <a:p>
+            <a:fld id="{6EB0AFAF-01AD-403D-8986-94521B07DECF}" type="slidenum">
+              <a:rPr lang="fr-FR" smtClean="0"/>
+              <a:t>2</a:t>
+            </a:fld>
+            <a:endParaRPr lang="fr-FR"/>
           </a:p>
         </p:txBody>
       </p:sp>
@@ -5046,7 +5134,7 @@
             </a:pPr>
             <a:r>
               <a:rPr lang="en-US" dirty="0"/>
-              <a:t>Some AFI/SAFI encodes NLRI with both</a:t>
+              <a:t>Some AFI/SAFI encodes NLRI in MP_REACH_NLRI with both</a:t>
             </a:r>
           </a:p>
           <a:p>
@@ -5102,6 +5190,9 @@
             </a:r>
           </a:p>
           <a:p>
+            <a:pPr marL="0" indent="0">
+              <a:buNone/>
+            </a:pPr>
             <a:endParaRPr lang="en-US" dirty="0"/>
           </a:p>
           <a:p>
@@ -5223,6 +5314,35 @@
               <a:latin typeface="Courier New" panose="02070309020205020404" pitchFamily="49" charset="0"/>
               <a:cs typeface="Courier New" panose="02070309020205020404" pitchFamily="49" charset="0"/>
             </a:endParaRPr>
+          </a:p>
+        </p:txBody>
+      </p:sp>
+      <p:sp>
+        <p:nvSpPr>
+          <p:cNvPr id="5" name="Espace réservé du numéro de diapositive 4">
+            <a:extLst>
+              <a:ext uri="{FF2B5EF4-FFF2-40B4-BE49-F238E27FC236}">
+                <a16:creationId xmlns:a16="http://schemas.microsoft.com/office/drawing/2014/main" id="{A69486E4-256C-3DB4-FA64-A29231896B3B}"/>
+              </a:ext>
+            </a:extLst>
+          </p:cNvPr>
+          <p:cNvSpPr>
+            <a:spLocks noGrp="1"/>
+          </p:cNvSpPr>
+          <p:nvPr>
+            <p:ph type="sldNum" sz="quarter" idx="12"/>
+          </p:nvPr>
+        </p:nvSpPr>
+        <p:spPr/>
+        <p:txBody>
+          <a:bodyPr/>
+          <a:lstStyle/>
+          <a:p>
+            <a:fld id="{6EB0AFAF-01AD-403D-8986-94521B07DECF}" type="slidenum">
+              <a:rPr lang="fr-FR" smtClean="0"/>
+              <a:t>3</a:t>
+            </a:fld>
+            <a:endParaRPr lang="fr-FR"/>
           </a:p>
         </p:txBody>
       </p:sp>
@@ -5278,14 +5398,26 @@
             <p:ph type="title"/>
           </p:nvPr>
         </p:nvSpPr>
-        <p:spPr/>
+        <p:spPr>
+          <a:xfrm>
+            <a:off x="838200" y="365125"/>
+            <a:ext cx="10878178" cy="1325563"/>
+          </a:xfrm>
+        </p:spPr>
         <p:txBody>
           <a:bodyPr/>
           <a:lstStyle/>
           <a:p>
             <a:r>
               <a:rPr lang="en-US" dirty="0"/>
-              <a:t>Error handling with non-key data </a:t>
+              <a:t>MP_REACH_NLRI error handling</a:t>
+            </a:r>
+            <a:br>
+              <a:rPr lang="en-US" dirty="0"/>
+            </a:br>
+            <a:r>
+              <a:rPr lang="en-US" dirty="0"/>
+              <a:t>with non-key data </a:t>
             </a:r>
           </a:p>
         </p:txBody>
@@ -5346,7 +5478,7 @@
               <a:rPr lang="en-US" dirty="0">
                 <a:sym typeface="Wingdings" panose="05000000000000000000" pitchFamily="2" charset="2"/>
               </a:rPr>
-              <a:t> BGP session reset (high network impact, not likely recoverable)</a:t>
+              <a:t> BGP session reset</a:t>
             </a:r>
           </a:p>
           <a:p>
@@ -5418,6 +5550,35 @@
           </a:p>
           <a:p>
             <a:endParaRPr lang="en-US" dirty="0"/>
+          </a:p>
+        </p:txBody>
+      </p:sp>
+      <p:sp>
+        <p:nvSpPr>
+          <p:cNvPr id="4" name="Espace réservé du numéro de diapositive 3">
+            <a:extLst>
+              <a:ext uri="{FF2B5EF4-FFF2-40B4-BE49-F238E27FC236}">
+                <a16:creationId xmlns:a16="http://schemas.microsoft.com/office/drawing/2014/main" id="{A2C2040E-6A34-4211-F77F-E37DEDAF6A7B}"/>
+              </a:ext>
+            </a:extLst>
+          </p:cNvPr>
+          <p:cNvSpPr>
+            <a:spLocks noGrp="1"/>
+          </p:cNvSpPr>
+          <p:nvPr>
+            <p:ph type="sldNum" sz="quarter" idx="12"/>
+          </p:nvPr>
+        </p:nvSpPr>
+        <p:spPr/>
+        <p:txBody>
+          <a:bodyPr/>
+          <a:lstStyle/>
+          <a:p>
+            <a:fld id="{6EB0AFAF-01AD-403D-8986-94521B07DECF}" type="slidenum">
+              <a:rPr lang="fr-FR" smtClean="0"/>
+              <a:t>4</a:t>
+            </a:fld>
+            <a:endParaRPr lang="fr-FR"/>
           </a:p>
         </p:txBody>
       </p:sp>
@@ -5556,6 +5717,35 @@
           </a:p>
         </p:txBody>
       </p:sp>
+      <p:sp>
+        <p:nvSpPr>
+          <p:cNvPr id="4" name="Espace réservé du numéro de diapositive 3">
+            <a:extLst>
+              <a:ext uri="{FF2B5EF4-FFF2-40B4-BE49-F238E27FC236}">
+                <a16:creationId xmlns:a16="http://schemas.microsoft.com/office/drawing/2014/main" id="{7A37B40E-7F79-CDCD-FF35-111D225491C3}"/>
+              </a:ext>
+            </a:extLst>
+          </p:cNvPr>
+          <p:cNvSpPr>
+            <a:spLocks noGrp="1"/>
+          </p:cNvSpPr>
+          <p:nvPr>
+            <p:ph type="sldNum" sz="quarter" idx="12"/>
+          </p:nvPr>
+        </p:nvSpPr>
+        <p:spPr/>
+        <p:txBody>
+          <a:bodyPr/>
+          <a:lstStyle/>
+          <a:p>
+            <a:fld id="{6EB0AFAF-01AD-403D-8986-94521B07DECF}" type="slidenum">
+              <a:rPr lang="fr-FR" smtClean="0"/>
+              <a:t>5</a:t>
+            </a:fld>
+            <a:endParaRPr lang="fr-FR"/>
+          </a:p>
+        </p:txBody>
+      </p:sp>
     </p:spTree>
     <p:extLst>
       <p:ext uri="{BB962C8B-B14F-4D97-AF65-F5344CB8AC3E}">
@@ -5718,6 +5908,35 @@
           </a:p>
         </p:txBody>
       </p:sp>
+      <p:sp>
+        <p:nvSpPr>
+          <p:cNvPr id="4" name="Espace réservé du numéro de diapositive 3">
+            <a:extLst>
+              <a:ext uri="{FF2B5EF4-FFF2-40B4-BE49-F238E27FC236}">
+                <a16:creationId xmlns:a16="http://schemas.microsoft.com/office/drawing/2014/main" id="{CA445FB7-1B2F-C935-2DF2-C06144FBA298}"/>
+              </a:ext>
+            </a:extLst>
+          </p:cNvPr>
+          <p:cNvSpPr>
+            <a:spLocks noGrp="1"/>
+          </p:cNvSpPr>
+          <p:nvPr>
+            <p:ph type="sldNum" sz="quarter" idx="12"/>
+          </p:nvPr>
+        </p:nvSpPr>
+        <p:spPr/>
+        <p:txBody>
+          <a:bodyPr/>
+          <a:lstStyle/>
+          <a:p>
+            <a:fld id="{6EB0AFAF-01AD-403D-8986-94521B07DECF}" type="slidenum">
+              <a:rPr lang="fr-FR" smtClean="0"/>
+              <a:t>6</a:t>
+            </a:fld>
+            <a:endParaRPr lang="fr-FR"/>
+          </a:p>
+        </p:txBody>
+      </p:sp>
     </p:spTree>
     <p:extLst>
       <p:ext uri="{BB962C8B-B14F-4D97-AF65-F5344CB8AC3E}">
@@ -6018,7 +6237,7 @@
                   <a:schemeClr val="tx1"/>
                 </a:solidFill>
               </a:rPr>
-              <a:t>PE1</a:t>
+              <a:t>PE5</a:t>
             </a:r>
           </a:p>
         </p:txBody>
@@ -6764,10 +6983,6 @@
             <a:pPr lvl="1"/>
             <a:endParaRPr lang="en-US" dirty="0"/>
           </a:p>
-          <a:p>
-            <a:pPr lvl="1"/>
-            <a:endParaRPr lang="en-US" dirty="0"/>
-          </a:p>
         </p:txBody>
       </p:sp>
       <p:sp>
@@ -6802,6 +7017,35 @@
               <a:rPr lang="en-US" dirty="0"/>
               <a:t>A different color indicates a different implementation</a:t>
             </a:r>
+          </a:p>
+        </p:txBody>
+      </p:sp>
+      <p:sp>
+        <p:nvSpPr>
+          <p:cNvPr id="3" name="Espace réservé du numéro de diapositive 2">
+            <a:extLst>
+              <a:ext uri="{FF2B5EF4-FFF2-40B4-BE49-F238E27FC236}">
+                <a16:creationId xmlns:a16="http://schemas.microsoft.com/office/drawing/2014/main" id="{4CDC7DE5-FB86-AED0-FDBD-588D51B92FED}"/>
+              </a:ext>
+            </a:extLst>
+          </p:cNvPr>
+          <p:cNvSpPr>
+            <a:spLocks noGrp="1"/>
+          </p:cNvSpPr>
+          <p:nvPr>
+            <p:ph type="sldNum" sz="quarter" idx="12"/>
+          </p:nvPr>
+        </p:nvSpPr>
+        <p:spPr/>
+        <p:txBody>
+          <a:bodyPr/>
+          <a:lstStyle/>
+          <a:p>
+            <a:fld id="{6EB0AFAF-01AD-403D-8986-94521B07DECF}" type="slidenum">
+              <a:rPr lang="fr-FR" smtClean="0"/>
+              <a:t>7</a:t>
+            </a:fld>
+            <a:endParaRPr lang="fr-FR"/>
           </a:p>
         </p:txBody>
       </p:sp>
@@ -7100,7 +7344,7 @@
                   <a:schemeClr val="tx1"/>
                 </a:solidFill>
               </a:rPr>
-              <a:t>PE1</a:t>
+              <a:t>PE5</a:t>
             </a:r>
           </a:p>
         </p:txBody>
@@ -7754,7 +7998,7 @@
         <p:spPr>
           <a:xfrm>
             <a:off x="838200" y="1825625"/>
-            <a:ext cx="5675383" cy="4351338"/>
+            <a:ext cx="5983071" cy="4351338"/>
           </a:xfrm>
         </p:spPr>
         <p:txBody>
@@ -7824,7 +8068,7 @@
               <a:rPr lang="en-US" dirty="0">
                 <a:sym typeface="Wingdings" panose="05000000000000000000" pitchFamily="2" charset="2"/>
               </a:rPr>
-              <a:t> can’t treat as withdraw</a:t>
+              <a:t> can’t treat-as-withdraw</a:t>
             </a:r>
           </a:p>
           <a:p>
@@ -7917,6 +8161,35 @@
               <a:rPr lang="en-US" dirty="0"/>
               <a:t>A different color indicates a different implementation</a:t>
             </a:r>
+          </a:p>
+        </p:txBody>
+      </p:sp>
+      <p:sp>
+        <p:nvSpPr>
+          <p:cNvPr id="3" name="Espace réservé du numéro de diapositive 2">
+            <a:extLst>
+              <a:ext uri="{FF2B5EF4-FFF2-40B4-BE49-F238E27FC236}">
+                <a16:creationId xmlns:a16="http://schemas.microsoft.com/office/drawing/2014/main" id="{5361E6DC-15B9-59DA-08B6-7A4B45C8A381}"/>
+              </a:ext>
+            </a:extLst>
+          </p:cNvPr>
+          <p:cNvSpPr>
+            <a:spLocks noGrp="1"/>
+          </p:cNvSpPr>
+          <p:nvPr>
+            <p:ph type="sldNum" sz="quarter" idx="12"/>
+          </p:nvPr>
+        </p:nvSpPr>
+        <p:spPr/>
+        <p:txBody>
+          <a:bodyPr/>
+          <a:lstStyle/>
+          <a:p>
+            <a:fld id="{6EB0AFAF-01AD-403D-8986-94521B07DECF}" type="slidenum">
+              <a:rPr lang="fr-FR" smtClean="0"/>
+              <a:t>8</a:t>
+            </a:fld>
+            <a:endParaRPr lang="fr-FR"/>
           </a:p>
         </p:txBody>
       </p:sp>
@@ -9327,6 +9600,35 @@
               <a:t>non-key data</a:t>
             </a:r>
             <a:endParaRPr lang="en-US" sz="1600" dirty="0"/>
+          </a:p>
+        </p:txBody>
+      </p:sp>
+      <p:sp>
+        <p:nvSpPr>
+          <p:cNvPr id="4" name="Espace réservé du numéro de diapositive 3">
+            <a:extLst>
+              <a:ext uri="{FF2B5EF4-FFF2-40B4-BE49-F238E27FC236}">
+                <a16:creationId xmlns:a16="http://schemas.microsoft.com/office/drawing/2014/main" id="{D68DA824-67EE-9207-8A6E-345C7A1109C2}"/>
+              </a:ext>
+            </a:extLst>
+          </p:cNvPr>
+          <p:cNvSpPr>
+            <a:spLocks noGrp="1"/>
+          </p:cNvSpPr>
+          <p:nvPr>
+            <p:ph type="sldNum" sz="quarter" idx="12"/>
+          </p:nvPr>
+        </p:nvSpPr>
+        <p:spPr/>
+        <p:txBody>
+          <a:bodyPr/>
+          <a:lstStyle/>
+          <a:p>
+            <a:fld id="{6EB0AFAF-01AD-403D-8986-94521B07DECF}" type="slidenum">
+              <a:rPr lang="fr-FR" smtClean="0"/>
+              <a:t>9</a:t>
+            </a:fld>
+            <a:endParaRPr lang="fr-FR"/>
           </a:p>
         </p:txBody>
       </p:sp>

</xml_diff>